<commit_message>
feat: deduplicate identical crops into one shared media file
</commit_message>
<xml_diff>
--- a/tests/fixtures/crop-sample.pptx
+++ b/tests/fixtures/crop-sample.pptx
@@ -323,6 +323,29 @@
           </a:prstGeom>
         </p:spPr>
       </p:pic>
+      <p:pic>
+        <p:nvPicPr>
+          <p:cNvPr id="7" name="Crop Dedup"/>
+          <p:cNvPicPr/>
+          <p:nvPr/>
+        </p:nvPicPr>
+        <p:blipFill>
+          <a:blip xmlns:r="http://schemas.openxmlformats.org/officeDocument/2006/relationships" xmlns:a="http://schemas.openxmlformats.org/drawingml/2006/main" r:embed="rIdImgCrop"/>
+          <a:srcRect xmlns:a="http://schemas.openxmlformats.org/drawingml/2006/main" l="10000" t="10000" r="10000" b="10000"/>
+          <a:stretch xmlns:a="http://schemas.openxmlformats.org/drawingml/2006/main">
+            <a:fillRect/>
+          </a:stretch>
+        </p:blipFill>
+        <p:spPr>
+          <a:xfrm xmlns:a="http://schemas.openxmlformats.org/drawingml/2006/main">
+            <a:off x="914400" y="5029200"/>
+            <a:ext cx="1828800" cy="1828800"/>
+          </a:xfrm>
+          <a:prstGeom xmlns:a="http://schemas.openxmlformats.org/drawingml/2006/main" prst="rect">
+            <a:avLst/>
+          </a:prstGeom>
+        </p:spPr>
+      </p:pic>
     </p:spTree>
   </p:cSld>
   <p:clrMapOvr>

</xml_diff>